<commit_message>
Align project guidance with agent-efficiency thesis
Amp-Thread-ID: https://ampcode.com/threads/T-019fd556-5142-753c-ae51-a2c3196c3b6d
Co-authored-by: Austin Barwick <austin.barwick@hey.com>
</commit_message>
<xml_diff>
--- a/docs/investor-deck.pptx
+++ b/docs/investor-deck.pptx
@@ -518,7 +518,7 @@
           <a:lstStyle/>
           <a:p>
             <a:r>
-              <a:t>AIL is not another coding agent. It is the control layer beneath coding agents: an executable language plus a compiler interface that makes consequences, authority, validation, and publication mechanically inspectable. Today we can demonstrate the mechanism on a bounded compiler slice. We are raising to prove the economic result on representative workloads.</a:t>
+              <a:t>AIL is not another coding agent. It is the control layer beneath coding agents: an executable language plus a compiler interface that makes consequences, authority, validation, and publication mechanically inspectable. Today bounded mechanisms execute as specified. We have no official comparative evidence that they reduce total agent change cost; the funded program is intended to test that claim on representative workloads.</a:t>
             </a:r>
           </a:p>
         </p:txBody>
@@ -798,7 +798,7 @@
           <a:lstStyle/>
           <a:p>
             <a:r>
-              <a:t>The roadmap is evidence-gated. The current semantic mechanism is implemented on a bounded service slice. Next comes the active non-official operator pilot and then a locked comparative validation against strong mainstream-language tools. Production lowering and broader runtime work follow only if the economic signal survives. This avoids spending heavily on a backend before validating the agent advantage.</a:t>
+              <a:t>The repository currently has no active successor milestone. M27 retained one non-official usability observation. This slide proposes a funded evidence program: freeze fresh representative tasks, build only the bounded AIL capabilities needed to create a fair comparator, compare against mainstream languages with their normal strong tools, and make an explicit go, revise, or stop decision. Broader production and ecosystem investment follows only when the result or a concrete deployment requirement justifies it. Native lowering, LLVM integration, broader syntax, and self-hosting are not automatic phases or proof of agent efficiency.</a:t>
             </a:r>
           </a:p>
         </p:txBody>
@@ -1008,7 +1008,7 @@
           <a:lstStyle/>
           <a:p>
             <a:r>
-              <a:t>A compelling live demo needs an agent visibly using compiler feedback to avoid or repair a bad change. Use the locked CancelJob task. Let the agent make or receive a centralized candidate, show that behavior passes, then show the compiler’s compact policy result and structured drill-down. The agent repairs authority placement, validates, and publishes. Capture telemetry on-screen, but call it a demo run—not comparative proof. The formal experiment must give baseline languages their normal compilers, language servers, search, formatters, and tests.</a:t>
+              <a:t>M27 retained one complete non-official run. The operator received the seeded centralized candidate and its compact rejection; the evidence does not show the operator independently creating that bad candidate. The operator used structured contributors, moved authority to the domain handler, reran validation, and published the valid child. Present this as one recorded usability observation, not a comparative or statistical result. A formal experiment must give baseline languages their normal compilers, language servers, refactors, search, formatters, and tests.</a:t>
             </a:r>
           </a:p>
         </p:txBody>
@@ -1218,7 +1218,7 @@
           <a:lstStyle/>
           <a:p>
             <a:r>
-              <a:t>Modern compilers and language servers help, but the agent often still assembles a file-oriented view and reasons across it probabilistically. That reconstruction repeats after diagnostics and again during review. The opportunity is not to remove reasoning; it is to make mechanically knowable facts complete, structured, and revision-bound.</a:t>
+              <a:t>Modern compilers, language servers, refactors, search, and tests already expose substantial semantics. Even with those normal strong tools, the agent often still assembles a file-oriented view and reasons across parts of it probabilistically. That reconstruction repeats after diagnostics and again during review. AIL must demonstrate a further reduction in total work against that baseline, not against raw text editing.</a:t>
             </a:r>
           </a:p>
         </p:txBody>
@@ -5224,8 +5224,8 @@
                 </a:solidFill>
                 <a:latin typeface="Aptos"/>
               </a:rPr>
-              <a:t>Mechanism
-proven today</a:t>
+              <a:t>Bounded
+mechanisms run</a:t>
             </a:r>
           </a:p>
         </p:txBody>
@@ -6416,7 +6416,7 @@
                 </a:solidFill>
                 <a:latin typeface="Aptos"/>
               </a:rPr>
-              <a:t>The mechanism is working. The size of the economic advantage remains to be measured.</a:t>
+              <a:t>Bounded mechanisms execute as specified. Comparative advantage remains to be measured.</a:t>
             </a:r>
           </a:p>
         </p:txBody>
@@ -8070,7 +8070,7 @@
                 </a:solidFill>
                 <a:latin typeface="Aptos"/>
               </a:rPr>
-              <a:t>Mechanism first. Economics next. Production follows evidence.</a:t>
+              <a:t>Mechanism first. Economics next. Production only when justified.</a:t>
             </a:r>
           </a:p>
         </p:txBody>
@@ -8152,7 +8152,7 @@
                 </a:solidFill>
                 <a:latin typeface="Aptos"/>
               </a:rPr>
-              <a:t>NOW</a:t>
+              <a:t>DONE</a:t>
             </a:r>
           </a:p>
         </p:txBody>
@@ -8234,7 +8234,7 @@
                 </a:solidFill>
                 <a:latin typeface="Aptos"/>
               </a:rPr>
-              <a:t>Semantic oracle</a:t>
+              <a:t>Bounded mechanism</a:t>
             </a:r>
           </a:p>
         </p:txBody>
@@ -8269,9 +8269,9 @@
                 </a:solidFill>
                 <a:latin typeface="Aptos"/>
               </a:rPr>
-              <a:t>parse • check • execute
-impact • transactions
-architecture policy</a:t>
+              <a:t>semantic oracle
+change transactions
+M27 observation</a:t>
             </a:r>
           </a:p>
         </p:txBody>
@@ -8388,7 +8388,7 @@
                 </a:solidFill>
                 <a:latin typeface="Aptos"/>
               </a:rPr>
-              <a:t>NEXT</a:t>
+              <a:t>TEST</a:t>
             </a:r>
           </a:p>
         </p:txBody>
@@ -8505,9 +8505,9 @@
                 </a:solidFill>
                 <a:latin typeface="Aptos"/>
               </a:rPr>
-              <a:t>operator pilot
-locked baseline trials
-blind review study</a:t>
+              <a:t>fresh held-out tasks
+bounded comparator work
+strong baseline trials</a:t>
             </a:r>
           </a:p>
         </p:txBody>
@@ -8624,7 +8624,7 @@
                 </a:solidFill>
                 <a:latin typeface="Aptos"/>
               </a:rPr>
-              <a:t>THEN</a:t>
+              <a:t>DECIDE</a:t>
             </a:r>
           </a:p>
         </p:txBody>
@@ -8706,7 +8706,7 @@
                 </a:solidFill>
                 <a:latin typeface="Aptos"/>
               </a:rPr>
-              <a:t>Production wedge</a:t>
+              <a:t>Go / revise / stop</a:t>
             </a:r>
           </a:p>
         </p:txBody>
@@ -8741,9 +8741,9 @@
                 </a:solidFill>
                 <a:latin typeface="Aptos"/>
               </a:rPr>
-              <a:t>broader service core
-production lowering
-runtime + I/O</a:t>
+              <a:t>correctness first
+total change cost
+generalization</a:t>
             </a:r>
           </a:p>
         </p:txBody>
@@ -8860,7 +8860,7 @@
                 </a:solidFill>
                 <a:latin typeface="Aptos"/>
               </a:rPr>
-              <a:t>EXPAND</a:t>
+              <a:t>IF NEEDED</a:t>
             </a:r>
           </a:p>
         </p:txBody>
@@ -8942,7 +8942,7 @@
                 </a:solidFill>
                 <a:latin typeface="Aptos"/>
               </a:rPr>
-              <a:t>Default agent stack</a:t>
+              <a:t>Broader capability</a:t>
             </a:r>
           </a:p>
         </p:txBody>
@@ -8977,9 +8977,9 @@
                 </a:solidFill>
                 <a:latin typeface="Aptos"/>
               </a:rPr>
-              <a:t>packages • deployment
-more application classes
-ecosystem</a:t>
+              <a:t>language, runtime,
+lowering, or ecosystem
+work evidence requires</a:t>
             </a:r>
           </a:p>
         </p:txBody>
@@ -9008,13 +9008,13 @@
           <a:p>
             <a:pPr algn="ctr"/>
             <a:r>
-              <a:rPr sz="1300" b="1">
+              <a:rPr sz="1250" b="1">
                 <a:solidFill>
                   <a:srgbClr val="F5F7FA"/>
                 </a:solidFill>
                 <a:latin typeface="Aptos"/>
               </a:rPr>
-              <a:t>Gates, not dates: advance when correctness, comparative evidence, and deployment constraints are demonstrated.</a:t>
+              <a:t>Proposed evidence program—not an active repository roadmap. M27 is complete; no successor is selected.</a:t>
             </a:r>
           </a:p>
         </p:txBody>
@@ -11187,13 +11187,13 @@
           <a:p>
             <a:pPr algn="l"/>
             <a:r>
-              <a:rPr sz="2700" b="1">
+              <a:rPr sz="3000" b="1">
                 <a:solidFill>
                   <a:srgbClr val="F5F7FA"/>
                 </a:solidFill>
                 <a:latin typeface="Aptos"/>
               </a:rPr>
-              <a:t>Planned M27 demo: show an agent changing course</a:t>
+              <a:t>Retained M27 pilot: an operator changes course</a:t>
             </a:r>
           </a:p>
         </p:txBody>
@@ -11228,7 +11228,7 @@
                 </a:solidFill>
                 <a:latin typeface="Aptos"/>
               </a:rPr>
-              <a:t>Keep compiler stdout in the evidence layer; make the workflow visible in the room.</a:t>
+              <a:t>The seeded bad candidate was supplied; the recorded run demonstrates one repair, not comparative advantage.</a:t>
             </a:r>
           </a:p>
         </p:txBody>
@@ -11310,7 +11310,7 @@
                 </a:solidFill>
                 <a:latin typeface="Aptos"/>
               </a:rPr>
-              <a:t>TASK</a:t>
+              <a:t>INPUT</a:t>
             </a:r>
           </a:p>
         </p:txBody>
@@ -11345,7 +11345,8 @@
                 </a:solidFill>
                 <a:latin typeface="Aptos"/>
               </a:rPr>
-              <a:t>Add CancelJob</a:t>
+              <a:t>seeded centralized
+candidate</a:t>
             </a:r>
           </a:p>
         </p:txBody>
@@ -11462,7 +11463,7 @@
                 </a:solidFill>
                 <a:latin typeface="Aptos"/>
               </a:rPr>
-              <a:t>BASELINE</a:t>
+              <a:t>REJECTION</a:t>
             </a:r>
           </a:p>
         </p:txBody>
@@ -11497,8 +11498,8 @@
                 </a:solidFill>
                 <a:latin typeface="Aptos"/>
               </a:rPr>
-              <a:t>agent proposes
-centralized change</a:t>
+              <a:t>6/6 behavior
+publication denied</a:t>
             </a:r>
           </a:p>
         </p:txBody>
@@ -11615,7 +11616,7 @@
                 </a:solidFill>
                 <a:latin typeface="Aptos"/>
               </a:rPr>
-              <a:t>AIL QUERY</a:t>
+              <a:t>DRILL-DOWN</a:t>
             </a:r>
           </a:p>
         </p:txBody>
@@ -11650,7 +11651,7 @@
                 </a:solidFill>
                 <a:latin typeface="Aptos"/>
               </a:rPr>
-              <a:t>impact + policy
+              <a:t>exact policy
 contributors</a:t>
             </a:r>
           </a:p>
@@ -14233,7 +14234,7 @@
                 </a:solidFill>
                 <a:latin typeface="Aptos"/>
               </a:rPr>
-              <a:t>Files expose syntax. The agent still has to infer the semantic change surface.</a:t>
+              <a:t>Strong tools expose substantial semantics; agents still reconstruct parts of the change surface.</a:t>
             </a:r>
           </a:p>
         </p:txBody>

</xml_diff>

<commit_message>
Rewrite documentation around shipped compiler behavior
Amp-Thread-ID: https://ampcode.com/threads/T-019fdd9d-fe9d-742a-b4ab-25e71b0d7f21
Co-authored-by: Austin Barwick <austin.barwick@hey.com>
</commit_message>
<xml_diff>
--- a/docs/investor-deck.pptx
+++ b/docs/investor-deck.pptx
@@ -518,7 +518,7 @@
           <a:lstStyle/>
           <a:p>
             <a:r>
-              <a:t>AIL is not another coding agent. It is the control layer beneath coding agents: an executable language plus a compiler interface that makes consequences, authority, validation, and publication mechanically inspectable. Today bounded mechanisms execute as specified. We have no official comparative evidence that they reduce total agent change cost; the funded program is intended to test that claim on representative workloads.</a:t>
+              <a:t>AIL is not another coding agent. It is an executable language plus a compiler interface that makes consequences, authority, validation, and publication mechanically inspectable. The compiler runs today. No AIL-versus-baseline agent comparison has run.</a:t>
             </a:r>
           </a:p>
         </p:txBody>
@@ -798,7 +798,7 @@
           <a:lstStyle/>
           <a:p>
             <a:r>
-              <a:t>The repository currently has no active successor milestone. M27 retained one non-official usability observation. This slide proposes a funded evidence program: freeze fresh representative tasks, build only the bounded AIL capabilities needed to create a fair comparator, compare against mainstream languages with their normal strong tools, and make an explicit go, revise, or stop decision. Broader production and ecosystem investment follows only when the result or a concrete deployment requirement justifies it. Native lowering, LLVM integration, broader syntax, and self-hosting are not automatic phases or proof of agent efficiency.</a:t>
+              <a:t>M28 shipped modules, import aliases, qualified references, and ordinary calls. The repository has no active successor milestone. One possible next investment is to freeze representative tasks, build only the AIL capabilities needed for a fair comparator, and compare against mainstream languages with their normal strong tools. Native lowering, LLVM integration, broader syntax, and self-hosting are not automatic next steps.</a:t>
             </a:r>
           </a:p>
         </p:txBody>
@@ -868,7 +868,7 @@
           <a:lstStyle/>
           <a:p>
             <a:r>
-              <a:t>This boundary is deliberate. We have real compiler machinery and can demonstrate exact semantic impact and atomic architecture enforcement. We have not yet proved lower cost than Rust, Go, Python, or TypeScript with their normal tools. We also do not yet have native lowering, production I/O, general concurrency, or broad ecosystem support. The raise is for converting technical feasibility into comparative and production evidence.</a:t>
+              <a:t>The compiler provides exact semantic impact for the M19 contract and atomic enforcement of the M24 architecture rules. No comparison has yet shown lower cost than Rust, Go, Python, or TypeScript with their normal tools. AIL also lacks native lowering, production I/O, general concurrency, and broad ecosystem support.</a:t>
             </a:r>
           </a:p>
         </p:txBody>
@@ -938,7 +938,7 @@
           <a:lstStyle/>
           <a:p>
             <a:r>
-              <a:t>The funded plan has three gates. First, use UC-003 and CancelJob only to calibrate the pipeline, then freeze fresh held-out design-partner tasks before adapting AIL to them. Build equivalent strong mainstream workspaces and pre-register a fixed maximum number of attempts, outcomes, exclusions, and reviewer rubric. Second, establish baseline distributions, lock AIL success targets before comparative AIL trials, and treat completion rate and terminal failures as primary outcomes. Third, run randomized assessor-independent review and make a go, revise, or stop decision. The exact financing amount, runway, and team plan require founder input before external use.</a:t>
+              <a:t>First, use UC-003 and CancelJob to test the runner, then freeze fresh held-out tasks before adapting AIL to them. Build equivalent mainstream-language workspaces and fix the maximum attempts, outcomes, exclusions, and reviewer rubric before running. Second, establish baseline distributions and lock AIL success targets before AIL trials. Third, run randomized independent review and choose the next build from the results. Financing, runway, and team requirements are not specified here.</a:t>
             </a:r>
           </a:p>
         </p:txBody>
@@ -1008,7 +1008,7 @@
           <a:lstStyle/>
           <a:p>
             <a:r>
-              <a:t>M27 retained one complete non-official run. The operator received the seeded centralized candidate and its compact rejection; the evidence does not show the operator independently creating that bad candidate. The operator used structured contributors, moved authority to the domain handler, reran validation, and published the valid child. Present this as one recorded usability observation, not a comparative or statistical result. A formal experiment must give baseline languages their normal compilers, language servers, refactors, search, formatters, and tests.</a:t>
+              <a:t>M27 retained one complete run. The operator received the seeded centralized candidate and its compact rejection; the run does not show the operator independently creating that bad candidate. The operator used structured contributors, moved authority to the domain handler, reran validation, and published the valid child. A comparison must give baseline languages their normal compilers, language servers, refactors, search, formatters, and tests.</a:t>
             </a:r>
           </a:p>
         </p:txBody>
@@ -1078,7 +1078,7 @@
           <a:lstStyle/>
           <a:p>
             <a:r>
-              <a:t>The comparison uses the exact same task contract and correctness oracle. Baselines receive strong normal tooling. The same model and agent policy should be used where possible, with all version and permission differences recorded. Pre-register a fixed maximum number of attempts per cell. Completion and terminal-failure distributions are primary outcomes; token, time, and repair comparisons among successful runs are explicitly conditional secondary estimands. Reviewer effort uses randomized assessor-independent packages; reviewers are blinded to hypothesis and provenance where feasible, but not falsely described as treatment-blind when the language is visible.</a:t>
+              <a:t>The comparison uses the same task contract and correctness oracle. Baselines receive strong normal tooling. Use the same model and agent policy where possible, and record version and permission differences. Fix the maximum attempts per cell before starting. Completion and terminal-failure distributions are primary outcomes; token, time, and repair comparisons among successful runs are conditional secondary measurements. Randomize reviewer assignments. Reviewers can be blinded to the hypothesis and provenance where feasible, but not to a language that is visible in source.</a:t>
             </a:r>
           </a:p>
         </p:txBody>
@@ -1428,7 +1428,7 @@
           <a:lstStyle/>
           <a:p>
             <a:r>
-              <a:t>This is not a mock interface. The Rust compiler parses and checks canonical AIL, executes the reference service, stores immutable revisions, computes exact impact, validates whole-workspace schema evolution, and enforces architecture policy atomically. The counts here are repository facts, not performance claims: 37 public behavior fixtures, 12 relationship kinds in the impact graph, 23 architecture scenarios, and four equivalent baseline implementations.</a:t>
+              <a:t>This is not a mock interface. The Rust compiler parses and checks canonical AIL, executes the reference service, stores immutable revisions, computes exact impact, validates whole-workspace schema evolution, enforces architecture policy atomically, and supports modules, import aliases, qualified references, and ordinary calls. The counts here are repository facts, not performance claims: 37 public behavior fixtures, 12 relationship kinds in the impact graph, 23 architecture scenarios, and four equivalent baseline implementations.</a:t>
             </a:r>
           </a:p>
         </p:txBody>
@@ -1568,7 +1568,7 @@
           <a:lstStyle/>
           <a:p>
             <a:r>
-              <a:t>This is the strongest bounded transaction proof. All three frozen semantic candidates carry accepted six-of-six behavior evidence supplied at the transaction boundary. The compiler evaluates their validated semantic graphs against locked policy. The domain-owned version publishes. The centralized version is rolled back for dispatch growth and transport authority, state, and dependency violations. A superficial helper split is also rolled back because aggregate responsibility remains in transport. This is not yet a complete source-to-agent product loop.</a:t>
+              <a:t>All three frozen semantic candidates carry accepted six-of-six behavior results supplied at the transaction boundary. The compiler evaluates their validated semantic graphs against locked policy. The domain-owned version publishes. The centralized version is rolled back for dispatch growth and transport authority, state, and dependency violations. A superficial helper split is also rolled back because aggregate responsibility remains in transport. This is not yet a complete source-to-agent product loop.</a:t>
             </a:r>
           </a:p>
         </p:txBody>
@@ -4834,7 +4834,7 @@
                 </a:solidFill>
                 <a:latin typeface="Aptos"/>
               </a:rPr>
-              <a:t>The control layer for
+              <a:t>A programming language for
 software built by agents</a:t>
             </a:r>
           </a:p>
@@ -5224,8 +5224,8 @@
                 </a:solidFill>
                 <a:latin typeface="Aptos"/>
               </a:rPr>
-              <a:t>Bounded
-mechanisms run</a:t>
+              <a:t>Compiler
+runs today</a:t>
             </a:r>
           </a:p>
         </p:txBody>
@@ -6416,7 +6416,7 @@
                 </a:solidFill>
                 <a:latin typeface="Aptos"/>
               </a:rPr>
-              <a:t>Bounded mechanisms execute as specified. Comparative advantage remains to be measured.</a:t>
+              <a:t>Compiler mechanisms execute as specified. Comparative advantage remains to be measured.</a:t>
             </a:r>
           </a:p>
         </p:txBody>
@@ -8234,7 +8234,7 @@
                 </a:solidFill>
                 <a:latin typeface="Aptos"/>
               </a:rPr>
-              <a:t>Bounded mechanism</a:t>
+              <a:t>Working compiler</a:t>
             </a:r>
           </a:p>
         </p:txBody>
@@ -8269,9 +8269,9 @@
                 </a:solidFill>
                 <a:latin typeface="Aptos"/>
               </a:rPr>
-              <a:t>semantic oracle
+              <a:t>semantic inspection
 change transactions
-M27 observation</a:t>
+M28 calls + modules</a:t>
             </a:r>
           </a:p>
         </p:txBody>
@@ -8506,7 +8506,7 @@
                 <a:latin typeface="Aptos"/>
               </a:rPr>
               <a:t>fresh held-out tasks
-bounded comparator work
+required AIL capability
 strong baseline trials</a:t>
             </a:r>
           </a:p>
@@ -8706,7 +8706,7 @@
                 </a:solidFill>
                 <a:latin typeface="Aptos"/>
               </a:rPr>
-              <a:t>Go / revise / stop</a:t>
+              <a:t>Use the results</a:t>
             </a:r>
           </a:p>
         </p:txBody>
@@ -9014,7 +9014,7 @@
                 </a:solidFill>
                 <a:latin typeface="Aptos"/>
               </a:rPr>
-              <a:t>Proposed evidence program—not an active repository roadmap. M27 is complete; no successor is selected.</a:t>
+              <a:t>M28 is complete. No successor is active; this comparison is one possible next investment.</a:t>
             </a:r>
           </a:p>
         </p:txBody>
@@ -9075,7 +9075,7 @@
                 </a:solidFill>
                 <a:latin typeface="Aptos"/>
               </a:rPr>
-              <a:t>AIL  /  PROOF BOUNDARIES</a:t>
+              <a:t>AIL  /  CURRENT LIMITS</a:t>
             </a:r>
           </a:p>
         </p:txBody>
@@ -9139,13 +9139,13 @@
           <a:p>
             <a:pPr algn="l"/>
             <a:r>
-              <a:rPr sz="3000" b="1">
+              <a:rPr sz="2700" b="1">
                 <a:solidFill>
                   <a:srgbClr val="F5F7FA"/>
                 </a:solidFill>
                 <a:latin typeface="Aptos"/>
               </a:rPr>
-              <a:t>What is proven—and what the raise must prove</a:t>
+              <a:t>What works—and what remains to build or measure</a:t>
             </a:r>
           </a:p>
         </p:txBody>
@@ -9514,7 +9514,7 @@
                 </a:solidFill>
                 <a:latin typeface="Aptos"/>
               </a:rPr>
-              <a:t>Exact bounded schema-impact report</a:t>
+              <a:t>Exact schema-impact report for the M19 contract</a:t>
             </a:r>
           </a:p>
         </p:txBody>
@@ -10398,7 +10398,7 @@
                 </a:solidFill>
                 <a:latin typeface="Aptos"/>
               </a:rPr>
-              <a:t>OFFICIAL COMPARATIVE AGENT TRIALS: 0</a:t>
+              <a:t>AIL-VS-BASELINE AGENT TRIALS: 0</a:t>
             </a:r>
           </a:p>
         </p:txBody>
@@ -10459,7 +10459,7 @@
                 </a:solidFill>
                 <a:latin typeface="Aptos"/>
               </a:rPr>
-              <a:t>AIL  /  FUNDED VALIDATION</a:t>
+              <a:t>AIL  /  NEXT EXPERIMENT</a:t>
             </a:r>
           </a:p>
         </p:txBody>
@@ -10523,13 +10523,13 @@
           <a:p>
             <a:pPr algn="l"/>
             <a:r>
-              <a:rPr sz="2700" b="1">
+              <a:rPr sz="3000" b="1">
                 <a:solidFill>
                   <a:srgbClr val="F5F7FA"/>
                 </a:solidFill>
                 <a:latin typeface="Aptos"/>
               </a:rPr>
-              <a:t>Fund the experiment that can falsify the thesis</a:t>
+              <a:t>Run the comparison that can falsify the thesis</a:t>
             </a:r>
           </a:p>
         </p:txBody>
@@ -10564,7 +10564,7 @@
                 </a:solidFill>
                 <a:latin typeface="Aptos"/>
               </a:rPr>
-              <a:t>A concrete evidence program—not a request to believe an unmeasured speedup.</a:t>
+              <a:t>Measure the result instead of assuming a speedup.</a:t>
             </a:r>
           </a:p>
         </p:txBody>
@@ -11024,10 +11024,10 @@
                 </a:solidFill>
                 <a:latin typeface="Aptos"/>
               </a:rPr>
-              <a:t>Randomized assessor-independent review
+              <a:t>Independent randomized review
 Uncertainty + failure distributions
-Go / revise / stop gates
-Production-wedge decision</a:t>
+Choose the next build from results
+Production decision</a:t>
             </a:r>
           </a:p>
         </p:txBody>
@@ -13261,7 +13261,7 @@
                 </a:solidFill>
                 <a:latin typeface="Aptos"/>
               </a:rPr>
-              <a:t>assessor-independent time • questions • defects • confidence</a:t>
+              <a:t>independent reviewer time • questions • defects • confidence</a:t>
             </a:r>
           </a:p>
         </p:txBody>
@@ -15658,7 +15658,7 @@
                 </a:solidFill>
                 <a:latin typeface="Aptos"/>
               </a:rPr>
-              <a:t>AIL turns language guarantees into an agent control plane</a:t>
+              <a:t>AIL exposes language guarantees through the compiler</a:t>
             </a:r>
           </a:p>
         </p:txBody>
@@ -18008,7 +18008,7 @@
                 </a:solidFill>
                 <a:latin typeface="Aptos"/>
               </a:rPr>
-              <a:t>A real compiler already closes bounded change loops</a:t>
+              <a:t>The Rust compiler already validates complete changes</a:t>
             </a:r>
           </a:p>
         </p:txBody>
@@ -18043,7 +18043,7 @@
                 </a:solidFill>
                 <a:latin typeface="Aptos"/>
               </a:rPr>
-              <a:t>Authoritative Rust implementation; checked-in contracts and deterministic fixtures.</a:t>
+              <a:t>Checked-in contracts and deterministic fixtures define the behavior.</a:t>
             </a:r>
           </a:p>
         </p:txBody>
@@ -19276,7 +19276,7 @@
                 </a:solidFill>
                 <a:latin typeface="Aptos"/>
               </a:rPr>
-              <a:t>PROVEN: bounded semantics and deterministic enforcement  •  NOT PROVEN: comparative agent acceleration</a:t>
+              <a:t>WORKS NOW: deterministic compiler enforcement  •  NOT RUN: AIL-versus-baseline agent comparison</a:t>
             </a:r>
           </a:p>
         </p:txBody>

</xml_diff>